<commit_message>
Use the supplied reference and README conventions
</commit_message>
<xml_diff>
--- a/slides.pptx
+++ b/slides.pptx
@@ -517,7 +517,7 @@
           <a:p>
             <a:r>
               <a:rPr lang="en-US" dirty="0"/>
-              <a:t>Draft deck. Parts 1-3 are complete; Parts 4-5 are placeholders. The reference is our own grid solver until the supplied reference_solver.py arrives.</a:t>
+              <a:t>All reference numbers come from the supplied reference_results.npz; all random draws follow the supplied README conventions. Our own grid solver is used for the Part 1 illustrations and as an independent cross-check.</a:t>
             </a:r>
             <a:endParaRPr lang="en-US" dirty="0"/>
           </a:p>
@@ -693,7 +693,7 @@
           <a:p>
             <a:r>
               <a:rPr lang="en-US" dirty="0"/>
-              <a:t>Validation uses random start dates, so dates near t0 carry little weight. Case 0's selected checkpoint has a worse boundary than checkpoint 400 and loses 0.87 dollars at S0 = 60 in the fixed-start evaluation.</a:t>
+              <a:t>Validation means differ by less than about 1.3 paired standard errors, so selection is close to picking among equals. The value is flat near the optimal threshold, so validation barely reacts to boundary changes.</a:t>
             </a:r>
             <a:endParaRPr lang="en-US" dirty="0"/>
           </a:p>
@@ -1045,7 +1045,7 @@
           <a:p>
             <a:r>
               <a:rPr lang="en-US" dirty="0"/>
-              <a:t>The optimal boundary itself moves by only 0.26% of K between N = 180 and 360, 10 to 100 times less than the fitted errors, so changes of a fitted policy with N are learning error.</a:t>
+              <a:t>The optimal boundary itself moves by only 0.26% of K between N = 180 and 360, far less than the fitted errors, so changes of a fitted policy with N are learning error.</a:t>
             </a:r>
             <a:endParaRPr lang="en-US" dirty="0"/>
           </a:p>
@@ -1661,7 +1661,7 @@
           <a:p>
             <a:r>
               <a:rPr lang="en-US" dirty="0"/>
-              <a:t>The draw order must be checked against the supplied README before submission; changing it changes every Monte Carlo number but not the method.</a:t>
+              <a:t>Draw order and arithmetic follow the supplied README exactly, so the samples match the instructor run up to floating-point and library differences.</a:t>
             </a:r>
             <a:endParaRPr lang="en-US" dirty="0"/>
           </a:p>
@@ -3233,7 +3233,7 @@
                 <a:ea typeface="Calibri" pitchFamily="34" charset="-122"/>
                 <a:cs typeface="Calibri" pitchFamily="34" charset="-120"/>
               </a:rPr>
-              <a:t>Case 0: ckpt 2400</a:t>
+              <a:t>Case 0: ckpt 2000</a:t>
             </a:r>
             <a:endParaRPr lang="en-US" sz="1200" dirty="0"/>
           </a:p>
@@ -3244,13 +3244,13 @@
             <a:r>
               <a:rPr lang="en-US" sz="1200" dirty="0">
                 <a:solidFill>
-                  <a:srgbClr val="EB6834"/>
+                  <a:srgbClr val="5A5F6E"/>
                 </a:solidFill>
                 <a:latin typeface="Calibri" pitchFamily="34" charset="0"/>
                 <a:ea typeface="Calibri" pitchFamily="34" charset="-122"/>
                 <a:cs typeface="Calibri" pitchFamily="34" charset="-120"/>
               </a:rPr>
-              <a:t>E_mean 0.065 → 0.078</a:t>
+              <a:t>E_mean 0.069 → 0.072</a:t>
             </a:r>
             <a:endParaRPr lang="en-US" sz="1200" dirty="0"/>
           </a:p>
@@ -3316,7 +3316,7 @@
                 <a:ea typeface="Calibri" pitchFamily="34" charset="-122"/>
                 <a:cs typeface="Calibri" pitchFamily="34" charset="-120"/>
               </a:rPr>
-              <a:t>Case 1: ckpt 0</a:t>
+              <a:t>Case 1: ckpt 2000</a:t>
             </a:r>
             <a:endParaRPr lang="en-US" sz="1200" dirty="0"/>
           </a:p>
@@ -3333,7 +3333,7 @@
                 <a:ea typeface="Calibri" pitchFamily="34" charset="-122"/>
                 <a:cs typeface="Calibri" pitchFamily="34" charset="-120"/>
               </a:rPr>
-              <a:t>E_mean 0.019 → 0.019</a:t>
+              <a:t>E_mean 0.019 → 0.017</a:t>
             </a:r>
             <a:endParaRPr lang="en-US" sz="1200" dirty="0"/>
           </a:p>
@@ -3399,7 +3399,7 @@
                 <a:ea typeface="Calibri" pitchFamily="34" charset="-122"/>
                 <a:cs typeface="Calibri" pitchFamily="34" charset="-120"/>
               </a:rPr>
-              <a:t>Case 2: ckpt 2400</a:t>
+              <a:t>Case 2: ckpt 1200</a:t>
             </a:r>
             <a:endParaRPr lang="en-US" sz="1200" dirty="0"/>
           </a:p>
@@ -3410,13 +3410,13 @@
             <a:r>
               <a:rPr lang="en-US" sz="1200" dirty="0">
                 <a:solidFill>
-                  <a:srgbClr val="2A78D6"/>
+                  <a:srgbClr val="5A5F6E"/>
                 </a:solidFill>
                 <a:latin typeface="Calibri" pitchFamily="34" charset="0"/>
                 <a:ea typeface="Calibri" pitchFamily="34" charset="-122"/>
                 <a:cs typeface="Calibri" pitchFamily="34" charset="-120"/>
               </a:rPr>
-              <a:t>E_mean 0.056 → 0.023</a:t>
+              <a:t>E_mean 0.064 → 0.062</a:t>
             </a:r>
             <a:endParaRPr lang="en-US" sz="1200" dirty="0"/>
           </a:p>
@@ -3482,7 +3482,7 @@
                 <a:ea typeface="Calibri" pitchFamily="34" charset="-122"/>
                 <a:cs typeface="Calibri" pitchFamily="34" charset="-120"/>
               </a:rPr>
-              <a:t>Case 3: ckpt 0</a:t>
+              <a:t>Case 3: ckpt 2400</a:t>
             </a:r>
             <a:endParaRPr lang="en-US" sz="1200" dirty="0"/>
           </a:p>
@@ -3493,13 +3493,13 @@
             <a:r>
               <a:rPr lang="en-US" sz="1200" dirty="0">
                 <a:solidFill>
-                  <a:srgbClr val="5A5F6E"/>
+                  <a:srgbClr val="EB6834"/>
                 </a:solidFill>
                 <a:latin typeface="Calibri" pitchFamily="34" charset="0"/>
                 <a:ea typeface="Calibri" pitchFamily="34" charset="-122"/>
                 <a:cs typeface="Calibri" pitchFamily="34" charset="-120"/>
               </a:rPr>
-              <a:t>E_mean 0.043 → 0.043</a:t>
+              <a:t>E_mean 0.029 → 0.043</a:t>
             </a:r>
             <a:endParaRPr lang="en-US" sz="1200" dirty="0"/>
           </a:p>
@@ -3538,7 +3538,7 @@
                 <a:ea typeface="Calibri" pitchFamily="34" charset="-122"/>
                 <a:cs typeface="Calibri" pitchFamily="34" charset="-120"/>
               </a:rPr>
-              <a:t>Case 2: payoff training more than halved the boundary error. Case 0: the selected checkpoint drifted to b ≈ 0.49K near t₀, which few validation paths visit.</a:t>
+              <a:t>Checkpoint 0 was never selected, yet payoff training barely changed the boundary error in cases 0–2 and worsened it in case 3.</a:t>
             </a:r>
             <a:endParaRPr lang="en-US" sz="900" dirty="0"/>
           </a:p>
@@ -3877,7 +3877,7 @@
                 <a:ea typeface="Calibri" pitchFamily="34" charset="-122"/>
                 <a:cs typeface="Calibri" pitchFamily="34" charset="-120"/>
               </a:rPr>
-              <a:t>Left = after d₃: no dividend remains and the boundary rises to K; both fits are biased low (~0.15K).</a:t>
+              <a:t>Left = after d₃: no dividend remains and the boundary rises to K; LS is ~0.12K low, the NN only ~0.02K.</a:t>
             </a:r>
             <a:endParaRPr lang="en-US" sz="1200" dirty="0"/>
           </a:p>
@@ -4579,7 +4579,7 @@
                           <a:ea typeface="Calibri" pitchFamily="34" charset="-122"/>
                           <a:cs typeface="Calibri" pitchFamily="34" charset="-120"/>
                         </a:rPr>
-                        <a:t>20.653 (0.056)</a:t>
+                        <a:t>20.661 (0.056)</a:t>
                       </a:r>
                       <a:endParaRPr lang="en-US" sz="1200" dirty="0">
                         <a:latin typeface="Calibri" charset="0"/>
@@ -4647,7 +4647,7 @@
                           <a:ea typeface="Calibri" pitchFamily="34" charset="-122"/>
                           <a:cs typeface="Calibri" pitchFamily="34" charset="-120"/>
                         </a:rPr>
-                        <a:t>20.584 (0.056)</a:t>
+                        <a:t>20.632 (0.056)</a:t>
                       </a:r>
                       <a:endParaRPr lang="en-US" sz="1200" dirty="0">
                         <a:latin typeface="Calibri" charset="0"/>
@@ -4921,7 +4921,7 @@
                           <a:ea typeface="Calibri" pitchFamily="34" charset="-122"/>
                           <a:cs typeface="Calibri" pitchFamily="34" charset="-120"/>
                         </a:rPr>
-                        <a:t>8.648 (0.050)</a:t>
+                        <a:t>8.640 (0.050)</a:t>
                       </a:r>
                       <a:endParaRPr lang="en-US" sz="1200" dirty="0">
                         <a:latin typeface="Calibri" charset="0"/>
@@ -4989,7 +4989,7 @@
                           <a:ea typeface="Calibri" pitchFamily="34" charset="-122"/>
                           <a:cs typeface="Calibri" pitchFamily="34" charset="-120"/>
                         </a:rPr>
-                        <a:t>8.760 (0.046)</a:t>
+                        <a:t>8.623 (0.050)</a:t>
                       </a:r>
                       <a:endParaRPr lang="en-US" sz="1200" dirty="0">
                         <a:latin typeface="Calibri" charset="0"/>
@@ -5195,7 +5195,7 @@
                           <a:ea typeface="Calibri" pitchFamily="34" charset="-122"/>
                           <a:cs typeface="Calibri" pitchFamily="34" charset="-120"/>
                         </a:rPr>
-                        <a:t>22.1095</a:t>
+                        <a:t>22.1096</a:t>
                       </a:r>
                       <a:endParaRPr lang="en-US" sz="1200" dirty="0">
                         <a:latin typeface="Calibri" charset="0"/>
@@ -5263,7 +5263,7 @@
                           <a:ea typeface="Calibri" pitchFamily="34" charset="-122"/>
                           <a:cs typeface="Calibri" pitchFamily="34" charset="-120"/>
                         </a:rPr>
-                        <a:t>21.997 (0.063)</a:t>
+                        <a:t>22.017 (0.062)</a:t>
                       </a:r>
                       <a:endParaRPr lang="en-US" sz="1200" dirty="0">
                         <a:latin typeface="Calibri" charset="0"/>
@@ -5331,7 +5331,7 @@
                           <a:ea typeface="Calibri" pitchFamily="34" charset="-122"/>
                           <a:cs typeface="Calibri" pitchFamily="34" charset="-120"/>
                         </a:rPr>
-                        <a:t>22.010 (0.063)</a:t>
+                        <a:t>22.029 (0.058)</a:t>
                       </a:r>
                       <a:endParaRPr lang="en-US" sz="1200" dirty="0">
                         <a:latin typeface="Calibri" charset="0"/>
@@ -5605,7 +5605,7 @@
                           <a:ea typeface="Calibri" pitchFamily="34" charset="-122"/>
                           <a:cs typeface="Calibri" pitchFamily="34" charset="-120"/>
                         </a:rPr>
-                        <a:t>10.029 (0.055)</a:t>
+                        <a:t>10.043 (0.054)</a:t>
                       </a:r>
                       <a:endParaRPr lang="en-US" sz="1200" dirty="0">
                         <a:latin typeface="Calibri" charset="0"/>
@@ -5673,7 +5673,7 @@
                           <a:ea typeface="Calibri" pitchFamily="34" charset="-122"/>
                           <a:cs typeface="Calibri" pitchFamily="34" charset="-120"/>
                         </a:rPr>
-                        <a:t>10.033 (0.055)</a:t>
+                        <a:t>10.048 (0.053)</a:t>
                       </a:r>
                       <a:endParaRPr lang="en-US" sz="1200" dirty="0">
                         <a:latin typeface="Calibri" charset="0"/>
@@ -5947,7 +5947,7 @@
                           <a:ea typeface="Calibri" pitchFamily="34" charset="-122"/>
                           <a:cs typeface="Calibri" pitchFamily="34" charset="-120"/>
                         </a:rPr>
-                        <a:t>20.660 (0.054)</a:t>
+                        <a:t>20.601 (0.055)</a:t>
                       </a:r>
                       <a:endParaRPr lang="en-US" sz="1200" dirty="0">
                         <a:latin typeface="Calibri" charset="0"/>
@@ -6015,7 +6015,7 @@
                           <a:ea typeface="Calibri" pitchFamily="34" charset="-122"/>
                           <a:cs typeface="Calibri" pitchFamily="34" charset="-120"/>
                         </a:rPr>
-                        <a:t>20.822 (0.042)</a:t>
+                        <a:t>20.633 (0.055)</a:t>
                       </a:r>
                       <a:endParaRPr lang="en-US" sz="1200" dirty="0">
                         <a:latin typeface="Calibri" charset="0"/>
@@ -6289,7 +6289,7 @@
                           <a:ea typeface="Calibri" pitchFamily="34" charset="-122"/>
                           <a:cs typeface="Calibri" pitchFamily="34" charset="-120"/>
                         </a:rPr>
-                        <a:t>8.612 (0.049)</a:t>
+                        <a:t>8.586 (0.050)</a:t>
                       </a:r>
                       <a:endParaRPr lang="en-US" sz="1200" dirty="0">
                         <a:latin typeface="Calibri" charset="0"/>
@@ -6357,7 +6357,7 @@
                           <a:ea typeface="Calibri" pitchFamily="34" charset="-122"/>
                           <a:cs typeface="Calibri" pitchFamily="34" charset="-120"/>
                         </a:rPr>
-                        <a:t>8.688 (0.046)</a:t>
+                        <a:t>8.593 (0.050)</a:t>
                       </a:r>
                       <a:endParaRPr lang="en-US" sz="1200" dirty="0">
                         <a:latin typeface="Calibri" charset="0"/>
@@ -6631,7 +6631,7 @@
                           <a:ea typeface="Calibri" pitchFamily="34" charset="-122"/>
                           <a:cs typeface="Calibri" pitchFamily="34" charset="-120"/>
                         </a:rPr>
-                        <a:t>22.070 (0.063)</a:t>
+                        <a:t>22.087 (0.063)</a:t>
                       </a:r>
                       <a:endParaRPr lang="en-US" sz="1200" dirty="0">
                         <a:latin typeface="Calibri" charset="0"/>
@@ -6699,7 +6699,7 @@
                           <a:ea typeface="Calibri" pitchFamily="34" charset="-122"/>
                           <a:cs typeface="Calibri" pitchFamily="34" charset="-120"/>
                         </a:rPr>
-                        <a:t>22.065 (0.062)</a:t>
+                        <a:t>22.027 (0.055)</a:t>
                       </a:r>
                       <a:endParaRPr lang="en-US" sz="1200" dirty="0">
                         <a:latin typeface="Calibri" charset="0"/>
@@ -6973,7 +6973,7 @@
                           <a:ea typeface="Calibri" pitchFamily="34" charset="-122"/>
                           <a:cs typeface="Calibri" pitchFamily="34" charset="-120"/>
                         </a:rPr>
-                        <a:t>10.073 (0.055)</a:t>
+                        <a:t>10.072 (0.055)</a:t>
                       </a:r>
                       <a:endParaRPr lang="en-US" sz="1200" dirty="0">
                         <a:latin typeface="Calibri" charset="0"/>
@@ -7041,7 +7041,7 @@
                           <a:ea typeface="Calibri" pitchFamily="34" charset="-122"/>
                           <a:cs typeface="Calibri" pitchFamily="34" charset="-120"/>
                         </a:rPr>
-                        <a:t>10.073 (0.055)</a:t>
+                        <a:t>10.068 (0.052)</a:t>
                       </a:r>
                       <a:endParaRPr lang="en-US" sz="1200" dirty="0">
                         <a:latin typeface="Calibri" charset="0"/>
@@ -7157,7 +7157,7 @@
                 <a:ea typeface="Cambria" pitchFamily="34" charset="-122"/>
                 <a:cs typeface="Cambria" pitchFamily="34" charset="-120"/>
               </a:rPr>
-              <a:t>3–7 % | 2–8 %</a:t>
+              <a:t>3–7 % | 2–7 %</a:t>
             </a:r>
             <a:endParaRPr lang="en-US" sz="2400" dirty="0"/>
           </a:p>
@@ -7262,7 +7262,7 @@
                 <a:ea typeface="Cambria" pitchFamily="34" charset="-122"/>
                 <a:cs typeface="Cambria" pitchFamily="34" charset="-120"/>
               </a:rPr>
-              <a:t>0.02–0.19 $</a:t>
+              <a:t>0.02–0.25 $</a:t>
             </a:r>
             <a:endParaRPr lang="en-US" sz="2400" dirty="0"/>
           </a:p>
@@ -7340,7 +7340,7 @@
                 <a:ea typeface="Calibri" pitchFamily="34" charset="-122"/>
                 <a:cs typeface="Calibri" pitchFamily="34" charset="-120"/>
               </a:rPr>
-              <a:t>S₀ = 60 omitted: LS and the reference exercise at once (value 40); the NN loses 0.87 $ (case 0) and 0.03 $ (case 1) there. Smooth pasting makes price error roughly second order in boundary error.</a:t>
+              <a:t>S₀ = 60 omitted: every policy exercises at once (value 40) except the case-3 NN, which loses 0.045 $ there. Smooth pasting makes price error roughly second order in boundary error.</a:t>
             </a:r>
             <a:endParaRPr lang="en-US" sz="1050" dirty="0"/>
           </a:p>
@@ -7404,7 +7404,7 @@
                 <a:ea typeface="Cambria" pitchFamily="34" charset="-122"/>
                 <a:cs typeface="Cambria" pitchFamily="34" charset="-120"/>
               </a:rPr>
-              <a:t>Moving the boundary barely moves the price</a:t>
+              <a:t>Too early costs, a bit later is free</a:t>
             </a:r>
             <a:endParaRPr lang="en-US" sz="2800" dirty="0"/>
           </a:p>
@@ -7527,13 +7527,13 @@
             <a:r>
               <a:rPr lang="en-US" sz="2400" b="1" dirty="0">
                 <a:solidFill>
-                  <a:srgbClr val="EB6834"/>
+                  <a:srgbClr val="2A78D6"/>
                 </a:solidFill>
                 <a:latin typeface="Cambria" pitchFamily="34" charset="0"/>
                 <a:ea typeface="Cambria" pitchFamily="34" charset="-122"/>
                 <a:cs typeface="Cambria" pitchFamily="34" charset="-120"/>
               </a:rPr>
-              <a:t>-0.019 $</a:t>
+              <a:t>+0.022 $</a:t>
             </a:r>
             <a:endParaRPr lang="en-US" sz="2400" dirty="0"/>
           </a:p>
@@ -7572,7 +7572,7 @@
                 <a:ea typeface="Calibri" pitchFamily="34" charset="-122"/>
                 <a:cs typeface="Calibri" pitchFamily="34" charset="-120"/>
               </a:rPr>
-              <a:t>a = −0.02: SE 0.008; 17% of paths now exercise later</a:t>
+              <a:t>a = −0.02: SE 0.011; 22% of paths now exercise later</a:t>
             </a:r>
             <a:endParaRPr lang="en-US" sz="1100" dirty="0"/>
           </a:p>
@@ -7632,13 +7632,13 @@
             <a:r>
               <a:rPr lang="en-US" sz="2400" b="1" dirty="0">
                 <a:solidFill>
-                  <a:srgbClr val="2A78D6"/>
+                  <a:srgbClr val="EB6834"/>
                 </a:solidFill>
                 <a:latin typeface="Cambria" pitchFamily="34" charset="0"/>
                 <a:ea typeface="Cambria" pitchFamily="34" charset="-122"/>
                 <a:cs typeface="Cambria" pitchFamily="34" charset="-120"/>
               </a:rPr>
-              <a:t>+0.005 $</a:t>
+              <a:t>-0.016 $</a:t>
             </a:r>
             <a:endParaRPr lang="en-US" sz="2400" dirty="0"/>
           </a:p>
@@ -7677,7 +7677,7 @@
                 <a:ea typeface="Calibri" pitchFamily="34" charset="-122"/>
                 <a:cs typeface="Calibri" pitchFamily="34" charset="-120"/>
               </a:rPr>
-              <a:t>a = +0.02: SE 0.009; cap binds on 147 of 360 dates</a:t>
+              <a:t>a = +0.02: SE 0.011; cap binds on 148 of 360 dates</a:t>
             </a:r>
             <a:endParaRPr lang="en-US" sz="1100" dirty="0"/>
           </a:p>
@@ -7716,7 +7716,7 @@
                 <a:ea typeface="Calibri" pitchFamily="34" charset="-122"/>
                 <a:cs typeface="Calibri" pitchFamily="34" charset="-120"/>
               </a:rPr>
-              <a:t>Only paths that enter the shifted band change decision. The cap absorbs most of an upward shift (applied mean shift 0.014K). The NN sits ≈0.04K below the reference, so moving down hurts and moving up lands on the flat part.</a:t>
+              <a:t>Only paths entering the shifted band change decision; the cap absorbs much of an upward shift (applied mean shift 0.013K). The NN overshoots just after d₁, so exercising earlier hurts and waiting slightly longer helps.</a:t>
             </a:r>
             <a:endParaRPr lang="en-US" sz="1050" dirty="0"/>
           </a:p>
@@ -7938,7 +7938,7 @@
                 <a:ea typeface="Calibri" pitchFamily="34" charset="-122"/>
                 <a:cs typeface="Calibri" pitchFamily="34" charset="-120"/>
               </a:rPr>
-              <a:t>2–8% mean boundary error costs cents: the value is flat near the optimal threshold (smooth pasting).</a:t>
+              <a:t>2–7% mean boundary error costs cents to ~0.25 $: the value is flat near the optimal threshold (smooth pasting).</a:t>
             </a:r>
             <a:endParaRPr lang="en-US" sz="1400" dirty="0"/>
           </a:p>
@@ -8036,7 +8036,7 @@
                 <a:ea typeface="Calibri" pitchFamily="34" charset="-122"/>
                 <a:cs typeface="Calibri" pitchFamily="34" charset="-120"/>
               </a:rPr>
-              <a:t>Except where paths go  </a:t>
+              <a:t>Where paths decide  </a:t>
             </a:r>
             <a:pPr indent="0" marL="0">
               <a:buNone/>
@@ -8050,7 +8050,7 @@
                 <a:ea typeface="Calibri" pitchFamily="34" charset="-122"/>
                 <a:cs typeface="Calibri" pitchFamily="34" charset="-120"/>
               </a:rPr>
-              <a:t>a small error at a heavily visited state (case-0 NN at t₀, S₀ = 60) costs 0.87 $.</a:t>
+              <a:t>errors matter where paths cross the boundary: the case-3 NN has the smaller max error but the larger price loss.</a:t>
             </a:r>
             <a:endParaRPr lang="en-US" sz="1400" dirty="0"/>
           </a:p>
@@ -8274,7 +8274,7 @@
                 <a:ea typeface="Calibri" pitchFamily="34" charset="-122"/>
                 <a:cs typeface="Calibri" pitchFamily="34" charset="-120"/>
               </a:rPr>
-              <a:t>validation cannot separate checkpoints (all within ~2 SE); no fitted price exceeds the reference (max z = -0.65).</a:t>
+              <a:t>validation cannot separate checkpoints (all within ~2 SE); no fitted price exceeds the reference (max z = -0.37).</a:t>
             </a:r>
             <a:endParaRPr lang="en-US" sz="1400" dirty="0"/>
           </a:p>
@@ -8313,7 +8313,7 @@
                 <a:ea typeface="Calibri" pitchFamily="34" charset="-122"/>
                 <a:cs typeface="Calibri" pitchFamily="34" charset="-120"/>
               </a:rPr>
-              <a:t>Reference: our own validated grid solver (the supplied reference files were not available); draw order documented in the code.</a:t>
+              <a:t>Reference: supplied reference_results.npz (--verify passed); draws follow the supplied README; our own solver agrees to ~1e-5 $.</a:t>
             </a:r>
             <a:endParaRPr lang="en-US" sz="1100" dirty="0"/>
           </a:p>
@@ -9336,7 +9336,7 @@
                 <a:ea typeface="Calibri" pitchFamily="34" charset="-122"/>
                 <a:cs typeface="Calibri" pitchFamily="34" charset="-120"/>
               </a:rPr>
-              <a:t>Our own grid solver, N = 180, δ = 0.0125. The put-style call exercises one grid step early and loses interest K(1 − e^(−rh)).</a:t>
+              <a:t>Our own grid solver (Part 1 illustration), N = 180, δ = 0.0125. The put-style call exercises one grid step early and loses interest K(1 − e^(−rh)).</a:t>
             </a:r>
             <a:endParaRPr lang="en-US" sz="900" dirty="0"/>
           </a:p>
@@ -10691,7 +10691,7 @@
                 <a:ea typeface="Calibri" pitchFamily="34" charset="-122"/>
                 <a:cs typeface="Calibri" pitchFamily="34" charset="-120"/>
               </a:rPr>
-              <a:t>Part 2 — the reference is precise to ~1e-5 $; changing N changes the problem itself</a:t>
+              <a:t>Part 2 — supplied --verify: precise to ~2e-5 $; changing N changes the problem itself</a:t>
             </a:r>
             <a:endParaRPr lang="en-US" sz="1300" dirty="0"/>
           </a:p>
@@ -10948,7 +10948,7 @@
                           <a:ea typeface="Calibri" pitchFamily="34" charset="-122"/>
                           <a:cs typeface="Calibri" pitchFamily="34" charset="-120"/>
                         </a:rPr>
-                        <a:t>Spatial dx/2, dx/4</a:t>
+                        <a:t>Spatial ΔS 0.10 → 0.05</a:t>
                       </a:r>
                       <a:endParaRPr lang="en-US" sz="1200" dirty="0">
                         <a:latin typeface="Calibri" charset="0"/>
@@ -11084,7 +11084,7 @@
                           <a:ea typeface="Calibri" pitchFamily="34" charset="-122"/>
                           <a:cs typeface="Calibri" pitchFamily="34" charset="-120"/>
                         </a:rPr>
-                        <a:t>1.3e-3</a:t>
+                        <a:t>1.8e-3</a:t>
                       </a:r>
                       <a:endParaRPr lang="en-US" sz="1200" dirty="0">
                         <a:latin typeface="Calibri" charset="0"/>
@@ -11154,7 +11154,7 @@
                           <a:ea typeface="Calibri" pitchFamily="34" charset="-122"/>
                           <a:cs typeface="Calibri" pitchFamily="34" charset="-120"/>
                         </a:rPr>
-                        <a:t>Time integration h/2, h/4</a:t>
+                        <a:t>Time 16 → 32 substeps</a:t>
                       </a:r>
                       <a:endParaRPr lang="en-US" sz="1200" dirty="0">
                         <a:latin typeface="Calibri" charset="0"/>
@@ -11222,7 +11222,7 @@
                           <a:ea typeface="Calibri" pitchFamily="34" charset="-122"/>
                           <a:cs typeface="Calibri" pitchFamily="34" charset="-120"/>
                         </a:rPr>
-                        <a:t>7.2e-9</a:t>
+                        <a:t>1.8e-5</a:t>
                       </a:r>
                       <a:endParaRPr lang="en-US" sz="1200" dirty="0">
                         <a:latin typeface="Calibri" charset="0"/>
@@ -11290,7 +11290,7 @@
                           <a:ea typeface="Calibri" pitchFamily="34" charset="-122"/>
                           <a:cs typeface="Calibri" pitchFamily="34" charset="-120"/>
                         </a:rPr>
-                        <a:t>1.6e-6</a:t>
+                        <a:t>1.5e-3</a:t>
                       </a:r>
                       <a:endParaRPr lang="en-US" sz="1200" dirty="0">
                         <a:latin typeface="Calibri" charset="0"/>
@@ -11360,7 +11360,7 @@
                           <a:ea typeface="Calibri" pitchFamily="34" charset="-122"/>
                           <a:cs typeface="Calibri" pitchFamily="34" charset="-120"/>
                         </a:rPr>
-                        <a:t>Wider domain / kernel tails</a:t>
+                        <a:t>Our solver vs supplied arrays</a:t>
                       </a:r>
                       <a:endParaRPr lang="en-US" sz="1200" dirty="0">
                         <a:latin typeface="Calibri" charset="0"/>
@@ -11428,7 +11428,7 @@
                           <a:ea typeface="Calibri" pitchFamily="34" charset="-122"/>
                           <a:cs typeface="Calibri" pitchFamily="34" charset="-120"/>
                         </a:rPr>
-                        <a:t>0</a:t>
+                        <a:t>8.5e-6</a:t>
                       </a:r>
                       <a:endParaRPr lang="en-US" sz="1200" dirty="0">
                         <a:latin typeface="Calibri" charset="0"/>
@@ -11496,7 +11496,7 @@
                           <a:ea typeface="Calibri" pitchFamily="34" charset="-122"/>
                           <a:cs typeface="Calibri" pitchFamily="34" charset="-120"/>
                         </a:rPr>
-                        <a:t>≤ 3e-12</a:t>
+                        <a:t>1.1e-3</a:t>
                       </a:r>
                       <a:endParaRPr lang="en-US" sz="1200" dirty="0">
                         <a:latin typeface="Calibri" charset="0"/>
@@ -11702,7 +11702,7 @@
                           <a:ea typeface="Calibri" pitchFamily="34" charset="-122"/>
                           <a:cs typeface="Calibri" pitchFamily="34" charset="-120"/>
                         </a:rPr>
-                        <a:t>0.305</a:t>
+                        <a:t>0.306</a:t>
                       </a:r>
                       <a:endParaRPr lang="en-US" sz="1200" dirty="0">
                         <a:latin typeface="Calibri" charset="0"/>
@@ -11818,7 +11818,7 @@
                 <a:ea typeface="Calibri" pitchFamily="34" charset="-122"/>
                 <a:cs typeface="Calibri" pitchFamily="34" charset="-120"/>
               </a:rPr>
-              <a:t>Placeholder reference</a:t>
+              <a:t>Supplied reference</a:t>
             </a:r>
             <a:endParaRPr lang="en-US" sz="1100" dirty="0"/>
           </a:p>
@@ -11835,7 +11835,7 @@
                 <a:ea typeface="Calibri" pitchFamily="34" charset="-122"/>
                 <a:cs typeface="Calibri" pitchFamily="34" charset="-120"/>
               </a:rPr>
-              <a:t>Our own solver: exact Gaussian step on a log grid, dividend = exact 10-node shift, dx²/6 variance correction. European check ≈ 2e-5 $. Replace with the supplied -verify output.</a:t>
+              <a:t>reference_solver.py --verify passed: saved arrays match a recomputation (≤ 2e-10). Finite differences, ΔS = 0.05, 32 substeps. Our independent log-grid solver agrees to within the refinement changes.</a:t>
             </a:r>
             <a:endParaRPr lang="en-US" sz="1100" dirty="0"/>
           </a:p>
@@ -11901,7 +11901,7 @@
                 <a:ea typeface="Cambria" pitchFamily="34" charset="-122"/>
                 <a:cs typeface="Cambria" pitchFamily="34" charset="-120"/>
               </a:rPr>
-              <a:t>≈ 1e-5 $</a:t>
+              <a:t>≈ 2e-5 $</a:t>
             </a:r>
             <a:endParaRPr lang="en-US" sz="2800" dirty="0"/>
           </a:p>
@@ -12084,7 +12084,7 @@
                 <a:ea typeface="Calibri" pitchFamily="34" charset="-122"/>
                 <a:cs typeface="Calibri" pitchFamily="34" charset="-120"/>
               </a:rPr>
-              <a:t>A claimed accuracy gain smaller than the reference's own precision (~1e-5 $ in price, ~1e-3 $ in boundary) cannot be resolved.</a:t>
+              <a:t>A claimed accuracy gain smaller than the reference's own precision (~2e-5 $ in price, ~2e-3 $ in boundary) cannot be resolved.</a:t>
             </a:r>
             <a:endParaRPr lang="en-US" sz="900" dirty="0"/>
           </a:p>
@@ -12671,7 +12671,7 @@
                 <a:ea typeface="Calibri" pitchFamily="34" charset="-122"/>
                 <a:cs typeface="Calibri" pitchFamily="34" charset="-120"/>
               </a:rPr>
-              <a:t>Training mixture A: log-uniform on [0.001K, K] or uniform on [0.2K, 1.2K], each with probability 1/2.</a:t>
+              <a:t>Training mixture A (README rule): v, u uniform; A = K·0.001^(1−u) if v &lt; 1/2, else K(0.2 + u).</a:t>
             </a:r>
             <a:endParaRPr lang="en-US" sz="1300" dirty="0"/>
           </a:p>
@@ -12713,7 +12713,7 @@
                 <a:ea typeface="Calibri" pitchFamily="34" charset="-122"/>
                 <a:cs typeface="Calibri" pitchFamily="34" charset="-120"/>
               </a:rPr>
-              <a:t>Assumed draw order (README.md not yet available): coin, log-uniform, uniform per path, then the path normals.</a:t>
+              <a:t>All banks follow the README draw order and arithmetic: one default_rng per bank, starts then normals, log1p(−δ) before dividend indices.</a:t>
             </a:r>
             <a:endParaRPr lang="en-US" sz="1300" dirty="0"/>
           </a:p>
@@ -14003,7 +14003,7 @@
                           <a:ea typeface="Calibri" pitchFamily="34" charset="-122"/>
                           <a:cs typeface="Calibri" pitchFamily="34" charset="-120"/>
                         </a:rPr>
-                        <a:t>179 / 180</a:t>
+                        <a:t>176 / 180</a:t>
                       </a:r>
                       <a:endParaRPr lang="en-US" sz="1200" dirty="0">
                         <a:latin typeface="Calibri" charset="0"/>
@@ -14345,7 +14345,7 @@
                           <a:ea typeface="Calibri" pitchFamily="34" charset="-122"/>
                           <a:cs typeface="Calibri" pitchFamily="34" charset="-120"/>
                         </a:rPr>
-                        <a:t>142 / 180</a:t>
+                        <a:t>138 / 180</a:t>
                       </a:r>
                       <a:endParaRPr lang="en-US" sz="1200" dirty="0">
                         <a:latin typeface="Calibri" charset="0"/>
@@ -14413,7 +14413,7 @@
                           <a:ea typeface="Calibri" pitchFamily="34" charset="-122"/>
                           <a:cs typeface="Calibri" pitchFamily="34" charset="-120"/>
                         </a:rPr>
-                        <a:t>85</a:t>
+                        <a:t>83</a:t>
                       </a:r>
                       <a:endParaRPr lang="en-US" sz="1200" dirty="0">
                         <a:latin typeface="Calibri" charset="0"/>
@@ -15029,7 +15029,7 @@
                           <a:ea typeface="Calibri" pitchFamily="34" charset="-122"/>
                           <a:cs typeface="Calibri" pitchFamily="34" charset="-120"/>
                         </a:rPr>
-                        <a:t>264 / 360</a:t>
+                        <a:t>273 / 360</a:t>
                       </a:r>
                       <a:endParaRPr lang="en-US" sz="1200" dirty="0">
                         <a:latin typeface="Calibri" charset="0"/>
@@ -15097,7 +15097,7 @@
                           <a:ea typeface="Calibri" pitchFamily="34" charset="-122"/>
                           <a:cs typeface="Calibri" pitchFamily="34" charset="-120"/>
                         </a:rPr>
-                        <a:t>149</a:t>
+                        <a:t>154</a:t>
                       </a:r>
                       <a:endParaRPr lang="en-US" sz="1200" dirty="0">
                         <a:latin typeface="Calibri" charset="0"/>
@@ -15381,7 +15381,7 @@
                 <a:ea typeface="Calibri" pitchFamily="34" charset="-122"/>
                 <a:cs typeface="Calibri" pitchFamily="34" charset="-120"/>
               </a:rPr>
-              <a:t>Case 0, date j = 90. Selecting the largest crossing gives one exercise interval (0, b] and discards the spurious continuation pocket around s ≈ 3–33.</a:t>
+              <a:t>Case 0, date j = 90. Selecting the largest crossing gives one exercise interval (0, b] and discards the spurious continuation pocket around s ≈ 3–34.</a:t>
             </a:r>
             <a:endParaRPr lang="en-US" sz="900" dirty="0"/>
           </a:p>

</xml_diff>